<commit_message>
Agregar notas del orador a la presentacion y guion de defensa EP4 con tiempos
</commit_message>
<xml_diff>
--- a/EP3_Presentacion_Atlas.pptx
+++ b/EP3_Presentacion_Atlas.pptx
@@ -118,6 +118,1421 @@
     </a:lvl9pPr>
   </p:defaultTextStyle>
 </p:presentation>
+</file>
+
+<file path=ppt/notesMasters/notesMaster1.xml><?xml version="1.0" encoding="utf-8"?>
+<p:notesMaster xmlns:a="http://schemas.openxmlformats.org/drawingml/2006/main" xmlns:p="http://schemas.openxmlformats.org/presentationml/2006/main" xmlns:r="http://schemas.openxmlformats.org/officeDocument/2006/relationships">
+  <p:cSld>
+    <p:bg>
+      <p:bgRef idx="1001">
+        <a:schemeClr val="bg1"/>
+      </p:bgRef>
+    </p:bg>
+    <p:spTree>
+      <p:nvGrpSpPr>
+        <p:cNvPr id="1" name=""/>
+        <p:cNvGrpSpPr/>
+        <p:nvPr/>
+      </p:nvGrpSpPr>
+      <p:grpSpPr>
+        <a:xfrm>
+          <a:off x="0" y="0"/>
+          <a:ext cx="0" cy="0"/>
+          <a:chOff x="0" y="0"/>
+          <a:chExt cx="0" cy="0"/>
+        </a:xfrm>
+      </p:grpSpPr>
+      <p:sp>
+        <p:nvSpPr>
+          <p:cNvPr id="2" name="Header Placeholder 1"/>
+          <p:cNvSpPr>
+            <a:spLocks noGrp="1"/>
+          </p:cNvSpPr>
+          <p:nvPr>
+            <p:ph type="hdr" sz="quarter"/>
+          </p:nvPr>
+        </p:nvSpPr>
+        <p:spPr>
+          <a:xfrm>
+            <a:off x="0" y="0"/>
+            <a:ext cx="2971800" cy="457200"/>
+          </a:xfrm>
+          <a:prstGeom prst="rect">
+            <a:avLst/>
+          </a:prstGeom>
+        </p:spPr>
+        <p:txBody>
+          <a:bodyPr vert="horz" lIns="91440" tIns="45720" rIns="91440" bIns="45720" rtlCol="0"/>
+          <a:lstStyle>
+            <a:lvl1pPr algn="l">
+              <a:defRPr sz="1200"/>
+            </a:lvl1pPr>
+          </a:lstStyle>
+          <a:p>
+            <a:endParaRPr lang="en-US"/>
+          </a:p>
+        </p:txBody>
+      </p:sp>
+      <p:sp>
+        <p:nvSpPr>
+          <p:cNvPr id="3" name="Date Placeholder 2"/>
+          <p:cNvSpPr>
+            <a:spLocks noGrp="1"/>
+          </p:cNvSpPr>
+          <p:nvPr>
+            <p:ph type="dt" idx="1"/>
+          </p:nvPr>
+        </p:nvSpPr>
+        <p:spPr>
+          <a:xfrm>
+            <a:off x="3884613" y="0"/>
+            <a:ext cx="2971800" cy="457200"/>
+          </a:xfrm>
+          <a:prstGeom prst="rect">
+            <a:avLst/>
+          </a:prstGeom>
+        </p:spPr>
+        <p:txBody>
+          <a:bodyPr vert="horz" lIns="91440" tIns="45720" rIns="91440" bIns="45720" rtlCol="0"/>
+          <a:lstStyle>
+            <a:lvl1pPr algn="r">
+              <a:defRPr sz="1200"/>
+            </a:lvl1pPr>
+          </a:lstStyle>
+          <a:p>
+            <a:fld id="{0F89C1C7-3DCD-1040-A9CF-14679D8B5DDD}" type="datetimeFigureOut">
+              <a:rPr lang="en-US" smtClean="0"/>
+              <a:t>10/17/16</a:t>
+            </a:fld>
+            <a:endParaRPr lang="en-US"/>
+          </a:p>
+        </p:txBody>
+      </p:sp>
+      <p:sp>
+        <p:nvSpPr>
+          <p:cNvPr id="4" name="Slide Image Placeholder 3"/>
+          <p:cNvSpPr>
+            <a:spLocks noGrp="1" noRot="1" noChangeAspect="1"/>
+          </p:cNvSpPr>
+          <p:nvPr>
+            <p:ph type="sldImg" idx="2"/>
+          </p:nvPr>
+        </p:nvSpPr>
+        <p:spPr>
+          <a:xfrm>
+            <a:off x="1143000" y="685800"/>
+            <a:ext cx="4572000" cy="3429000"/>
+          </a:xfrm>
+          <a:prstGeom prst="rect">
+            <a:avLst/>
+          </a:prstGeom>
+          <a:noFill/>
+          <a:ln w="12700">
+            <a:solidFill>
+              <a:prstClr val="black"/>
+            </a:solidFill>
+          </a:ln>
+        </p:spPr>
+        <p:txBody>
+          <a:bodyPr vert="horz" lIns="91440" tIns="45720" rIns="91440" bIns="45720" rtlCol="0" anchor="ctr"/>
+          <a:lstStyle/>
+          <a:p>
+            <a:endParaRPr lang="en-US"/>
+          </a:p>
+        </p:txBody>
+      </p:sp>
+      <p:sp>
+        <p:nvSpPr>
+          <p:cNvPr id="5" name="Notes Placeholder 4"/>
+          <p:cNvSpPr>
+            <a:spLocks noGrp="1"/>
+          </p:cNvSpPr>
+          <p:nvPr>
+            <p:ph type="body" sz="quarter" idx="3"/>
+          </p:nvPr>
+        </p:nvSpPr>
+        <p:spPr>
+          <a:xfrm>
+            <a:off x="685800" y="4343400"/>
+            <a:ext cx="5486400" cy="4114800"/>
+          </a:xfrm>
+          <a:prstGeom prst="rect">
+            <a:avLst/>
+          </a:prstGeom>
+        </p:spPr>
+        <p:txBody>
+          <a:bodyPr vert="horz" lIns="91440" tIns="45720" rIns="91440" bIns="45720" rtlCol="0"/>
+          <a:lstStyle/>
+          <a:p>
+            <a:pPr lvl="0"/>
+            <a:r>
+              <a:rPr lang="en-US" smtClean="0"/>
+              <a:t>Click to edit Master text styles</a:t>
+            </a:r>
+          </a:p>
+          <a:p>
+            <a:pPr lvl="1"/>
+            <a:r>
+              <a:rPr lang="en-US" smtClean="0"/>
+              <a:t>Second level</a:t>
+            </a:r>
+          </a:p>
+          <a:p>
+            <a:pPr lvl="2"/>
+            <a:r>
+              <a:rPr lang="en-US" smtClean="0"/>
+              <a:t>Third level</a:t>
+            </a:r>
+          </a:p>
+          <a:p>
+            <a:pPr lvl="3"/>
+            <a:r>
+              <a:rPr lang="en-US" smtClean="0"/>
+              <a:t>Fourth level</a:t>
+            </a:r>
+          </a:p>
+          <a:p>
+            <a:pPr lvl="4"/>
+            <a:r>
+              <a:rPr lang="en-US" smtClean="0"/>
+              <a:t>Fifth level</a:t>
+            </a:r>
+            <a:endParaRPr lang="en-US"/>
+          </a:p>
+        </p:txBody>
+      </p:sp>
+      <p:sp>
+        <p:nvSpPr>
+          <p:cNvPr id="6" name="Footer Placeholder 5"/>
+          <p:cNvSpPr>
+            <a:spLocks noGrp="1"/>
+          </p:cNvSpPr>
+          <p:nvPr>
+            <p:ph type="ftr" sz="quarter" idx="4"/>
+          </p:nvPr>
+        </p:nvSpPr>
+        <p:spPr>
+          <a:xfrm>
+            <a:off x="0" y="8685213"/>
+            <a:ext cx="2971800" cy="457200"/>
+          </a:xfrm>
+          <a:prstGeom prst="rect">
+            <a:avLst/>
+          </a:prstGeom>
+        </p:spPr>
+        <p:txBody>
+          <a:bodyPr vert="horz" lIns="91440" tIns="45720" rIns="91440" bIns="45720" rtlCol="0" anchor="b"/>
+          <a:lstStyle>
+            <a:lvl1pPr algn="l">
+              <a:defRPr sz="1200"/>
+            </a:lvl1pPr>
+          </a:lstStyle>
+          <a:p>
+            <a:endParaRPr lang="en-US"/>
+          </a:p>
+        </p:txBody>
+      </p:sp>
+      <p:sp>
+        <p:nvSpPr>
+          <p:cNvPr id="7" name="Slide Number Placeholder 6"/>
+          <p:cNvSpPr>
+            <a:spLocks noGrp="1"/>
+          </p:cNvSpPr>
+          <p:nvPr>
+            <p:ph type="sldNum" sz="quarter" idx="5"/>
+          </p:nvPr>
+        </p:nvSpPr>
+        <p:spPr>
+          <a:xfrm>
+            <a:off x="3884613" y="8685213"/>
+            <a:ext cx="2971800" cy="457200"/>
+          </a:xfrm>
+          <a:prstGeom prst="rect">
+            <a:avLst/>
+          </a:prstGeom>
+        </p:spPr>
+        <p:txBody>
+          <a:bodyPr vert="horz" lIns="91440" tIns="45720" rIns="91440" bIns="45720" rtlCol="0" anchor="b"/>
+          <a:lstStyle>
+            <a:lvl1pPr algn="r">
+              <a:defRPr sz="1200"/>
+            </a:lvl1pPr>
+          </a:lstStyle>
+          <a:p>
+            <a:fld id="{BB5E49A5-4136-284D-997B-48E1D791AD67}" type="slidenum">
+              <a:rPr lang="en-US" smtClean="0"/>
+              <a:t>‹#›</a:t>
+            </a:fld>
+            <a:endParaRPr lang="en-US"/>
+          </a:p>
+        </p:txBody>
+      </p:sp>
+    </p:spTree>
+    <p:extLst>
+      <p:ext uri="{BB962C8B-B14F-4D97-AF65-F5344CB8AC3E}">
+        <p14:creationId xmlns:p14="http://schemas.microsoft.com/office/powerpoint/2010/main" val="2623252185"/>
+      </p:ext>
+    </p:extLst>
+  </p:cSld>
+  <p:clrMap bg1="lt1" tx1="dk1" bg2="lt2" tx2="dk2" accent1="accent1" accent2="accent2" accent3="accent3" accent4="accent4" accent5="accent5" accent6="accent6" hlink="hlink" folHlink="folHlink"/>
+  <p:notesStyle>
+    <a:lvl1pPr marL="0" algn="l" defTabSz="457200" rtl="0" eaLnBrk="1" latinLnBrk="0" hangingPunct="1">
+      <a:defRPr sz="1200" kern="1200">
+        <a:solidFill>
+          <a:schemeClr val="tx1"/>
+        </a:solidFill>
+        <a:latin typeface="+mn-lt"/>
+        <a:ea typeface="+mn-ea"/>
+        <a:cs typeface="+mn-cs"/>
+      </a:defRPr>
+    </a:lvl1pPr>
+    <a:lvl2pPr marL="457200" algn="l" defTabSz="457200" rtl="0" eaLnBrk="1" latinLnBrk="0" hangingPunct="1">
+      <a:defRPr sz="1200" kern="1200">
+        <a:solidFill>
+          <a:schemeClr val="tx1"/>
+        </a:solidFill>
+        <a:latin typeface="+mn-lt"/>
+        <a:ea typeface="+mn-ea"/>
+        <a:cs typeface="+mn-cs"/>
+      </a:defRPr>
+    </a:lvl2pPr>
+    <a:lvl3pPr marL="914400" algn="l" defTabSz="457200" rtl="0" eaLnBrk="1" latinLnBrk="0" hangingPunct="1">
+      <a:defRPr sz="1200" kern="1200">
+        <a:solidFill>
+          <a:schemeClr val="tx1"/>
+        </a:solidFill>
+        <a:latin typeface="+mn-lt"/>
+        <a:ea typeface="+mn-ea"/>
+        <a:cs typeface="+mn-cs"/>
+      </a:defRPr>
+    </a:lvl3pPr>
+    <a:lvl4pPr marL="1371600" algn="l" defTabSz="457200" rtl="0" eaLnBrk="1" latinLnBrk="0" hangingPunct="1">
+      <a:defRPr sz="1200" kern="1200">
+        <a:solidFill>
+          <a:schemeClr val="tx1"/>
+        </a:solidFill>
+        <a:latin typeface="+mn-lt"/>
+        <a:ea typeface="+mn-ea"/>
+        <a:cs typeface="+mn-cs"/>
+      </a:defRPr>
+    </a:lvl4pPr>
+    <a:lvl5pPr marL="1828800" algn="l" defTabSz="457200" rtl="0" eaLnBrk="1" latinLnBrk="0" hangingPunct="1">
+      <a:defRPr sz="1200" kern="1200">
+        <a:solidFill>
+          <a:schemeClr val="tx1"/>
+        </a:solidFill>
+        <a:latin typeface="+mn-lt"/>
+        <a:ea typeface="+mn-ea"/>
+        <a:cs typeface="+mn-cs"/>
+      </a:defRPr>
+    </a:lvl5pPr>
+    <a:lvl6pPr marL="2286000" algn="l" defTabSz="457200" rtl="0" eaLnBrk="1" latinLnBrk="0" hangingPunct="1">
+      <a:defRPr sz="1200" kern="1200">
+        <a:solidFill>
+          <a:schemeClr val="tx1"/>
+        </a:solidFill>
+        <a:latin typeface="+mn-lt"/>
+        <a:ea typeface="+mn-ea"/>
+        <a:cs typeface="+mn-cs"/>
+      </a:defRPr>
+    </a:lvl6pPr>
+    <a:lvl7pPr marL="2743200" algn="l" defTabSz="457200" rtl="0" eaLnBrk="1" latinLnBrk="0" hangingPunct="1">
+      <a:defRPr sz="1200" kern="1200">
+        <a:solidFill>
+          <a:schemeClr val="tx1"/>
+        </a:solidFill>
+        <a:latin typeface="+mn-lt"/>
+        <a:ea typeface="+mn-ea"/>
+        <a:cs typeface="+mn-cs"/>
+      </a:defRPr>
+    </a:lvl7pPr>
+    <a:lvl8pPr marL="3200400" algn="l" defTabSz="457200" rtl="0" eaLnBrk="1" latinLnBrk="0" hangingPunct="1">
+      <a:defRPr sz="1200" kern="1200">
+        <a:solidFill>
+          <a:schemeClr val="tx1"/>
+        </a:solidFill>
+        <a:latin typeface="+mn-lt"/>
+        <a:ea typeface="+mn-ea"/>
+        <a:cs typeface="+mn-cs"/>
+      </a:defRPr>
+    </a:lvl8pPr>
+    <a:lvl9pPr marL="3657600" algn="l" defTabSz="457200" rtl="0" eaLnBrk="1" latinLnBrk="0" hangingPunct="1">
+      <a:defRPr sz="1200" kern="1200">
+        <a:solidFill>
+          <a:schemeClr val="tx1"/>
+        </a:solidFill>
+        <a:latin typeface="+mn-lt"/>
+        <a:ea typeface="+mn-ea"/>
+        <a:cs typeface="+mn-cs"/>
+      </a:defRPr>
+    </a:lvl9pPr>
+  </p:notesStyle>
+</p:notesMaster>
+</file>
+
+<file path=ppt/notesSlides/notesSlide1.xml><?xml version="1.0" encoding="utf-8"?>
+<p:notes xmlns:a="http://schemas.openxmlformats.org/drawingml/2006/main" xmlns:p="http://schemas.openxmlformats.org/presentationml/2006/main" xmlns:r="http://schemas.openxmlformats.org/officeDocument/2006/relationships">
+  <p:cSld>
+    <p:spTree>
+      <p:nvGrpSpPr>
+        <p:cNvPr id="1" name=""/>
+        <p:cNvGrpSpPr/>
+        <p:nvPr/>
+      </p:nvGrpSpPr>
+      <p:grpSpPr>
+        <a:xfrm>
+          <a:off x="0" y="0"/>
+          <a:ext cx="0" cy="0"/>
+          <a:chOff x="0" y="0"/>
+          <a:chExt cx="0" cy="0"/>
+        </a:xfrm>
+      </p:grpSpPr>
+      <p:sp>
+        <p:nvSpPr>
+          <p:cNvPr id="2" name="Slide Image Placeholder 1"/>
+          <p:cNvSpPr>
+            <a:spLocks noGrp="1"/>
+          </p:cNvSpPr>
+          <p:nvPr>
+            <p:ph type="sldImg" idx="2"/>
+          </p:nvPr>
+        </p:nvSpPr>
+        <p:spPr/>
+      </p:sp>
+      <p:sp>
+        <p:nvSpPr>
+          <p:cNvPr id="3" name="Notes Placeholder 2"/>
+          <p:cNvSpPr>
+            <a:spLocks noGrp="1"/>
+          </p:cNvSpPr>
+          <p:nvPr>
+            <p:ph type="body" idx="3" sz="quarter"/>
+          </p:nvPr>
+        </p:nvSpPr>
+        <p:spPr/>
+        <p:txBody>
+          <a:bodyPr/>
+          <a:lstStyle/>
+          <a:p>
+            <a:r>
+              <a:t>[0:00-0:30] Saludo y presentación (30 s)</a:t>
+            </a:r>
+          </a:p>
+          <a:p>
+            <a:r>
+              <a:t>Buenos días. Somos Luis Tasso, Miguel Arredondo y Nicolas Iturrieta. Presentamos la verificación de seguridad y calidad del sistema Atlas, desarrollada para la Evaluación Parcial N.º 3. Anticipo la conclusión: el dictamen es NO CERTIFICADO, porque encontramos cuatro defectos críticos de seguridad que impiden su puesta en producción. A continuación explico el enfoque, la ejecución y la evidencia.</a:t>
+            </a:r>
+          </a:p>
+        </p:txBody>
+      </p:sp>
+      <p:sp>
+        <p:nvSpPr>
+          <p:cNvPr id="4" name="Slide Number Placeholder 3"/>
+          <p:cNvSpPr>
+            <a:spLocks noGrp="1"/>
+          </p:cNvSpPr>
+          <p:nvPr>
+            <p:ph type="sldNum" idx="5" sz="quarter"/>
+          </p:nvPr>
+        </p:nvSpPr>
+        <p:spPr/>
+      </p:sp>
+    </p:spTree>
+  </p:cSld>
+  <p:clrMapOvr>
+    <a:masterClrMapping/>
+  </p:clrMapOvr>
+</p:notes>
+</file>
+
+<file path=ppt/notesSlides/notesSlide10.xml><?xml version="1.0" encoding="utf-8"?>
+<p:notes xmlns:a="http://schemas.openxmlformats.org/drawingml/2006/main" xmlns:p="http://schemas.openxmlformats.org/presentationml/2006/main" xmlns:r="http://schemas.openxmlformats.org/officeDocument/2006/relationships">
+  <p:cSld>
+    <p:spTree>
+      <p:nvGrpSpPr>
+        <p:cNvPr id="1" name=""/>
+        <p:cNvGrpSpPr/>
+        <p:nvPr/>
+      </p:nvGrpSpPr>
+      <p:grpSpPr>
+        <a:xfrm>
+          <a:off x="0" y="0"/>
+          <a:ext cx="0" cy="0"/>
+          <a:chOff x="0" y="0"/>
+          <a:chExt cx="0" cy="0"/>
+        </a:xfrm>
+      </p:grpSpPr>
+      <p:sp>
+        <p:nvSpPr>
+          <p:cNvPr id="2" name="Slide Image Placeholder 1"/>
+          <p:cNvSpPr>
+            <a:spLocks noGrp="1"/>
+          </p:cNvSpPr>
+          <p:nvPr>
+            <p:ph type="sldImg" idx="2"/>
+          </p:nvPr>
+        </p:nvSpPr>
+        <p:spPr/>
+      </p:sp>
+      <p:sp>
+        <p:nvSpPr>
+          <p:cNvPr id="3" name="Notes Placeholder 2"/>
+          <p:cNvSpPr>
+            <a:spLocks noGrp="1"/>
+          </p:cNvSpPr>
+          <p:nvPr>
+            <p:ph type="body" idx="3" sz="quarter"/>
+          </p:nvPr>
+        </p:nvSpPr>
+        <p:spPr/>
+        <p:txBody>
+          <a:bodyPr/>
+          <a:lstStyle/>
+          <a:p>
+            <a:r>
+              <a:t>[6:40-7:30] Clasificación de defectos (50 s)</a:t>
+            </a:r>
+          </a:p>
+          <a:p>
+            <a:r>
+              <a:t>Clasificamos los 11 incidentes con una escala de cuatro niveles. CRITICO: 4 casos, que impiden operar o exponen datos sensibles —el acceso sin token, las credenciales en texto claro, la subida sin validación y el secreto en el código—. GRAVE: 5 casos, entre ellos el JWT_SECRET inseguro, el CORS abierto, la ausencia de rate-limit, los errores 500 y el uso de localStorage. MODERADO: la latencia artificial. Y LEVE: los code smells de ESLint. La regla que aplicamos es que un software con defectos CRITICO abiertos nunca debe certificarse.</a:t>
+            </a:r>
+          </a:p>
+        </p:txBody>
+      </p:sp>
+      <p:sp>
+        <p:nvSpPr>
+          <p:cNvPr id="4" name="Slide Number Placeholder 3"/>
+          <p:cNvSpPr>
+            <a:spLocks noGrp="1"/>
+          </p:cNvSpPr>
+          <p:nvPr>
+            <p:ph type="sldNum" idx="5" sz="quarter"/>
+          </p:nvPr>
+        </p:nvSpPr>
+        <p:spPr/>
+      </p:sp>
+    </p:spTree>
+  </p:cSld>
+  <p:clrMapOvr>
+    <a:masterClrMapping/>
+  </p:clrMapOvr>
+</p:notes>
+</file>
+
+<file path=ppt/notesSlides/notesSlide11.xml><?xml version="1.0" encoding="utf-8"?>
+<p:notes xmlns:a="http://schemas.openxmlformats.org/drawingml/2006/main" xmlns:p="http://schemas.openxmlformats.org/presentationml/2006/main" xmlns:r="http://schemas.openxmlformats.org/officeDocument/2006/relationships">
+  <p:cSld>
+    <p:spTree>
+      <p:nvGrpSpPr>
+        <p:cNvPr id="1" name=""/>
+        <p:cNvGrpSpPr/>
+        <p:nvPr/>
+      </p:nvGrpSpPr>
+      <p:grpSpPr>
+        <a:xfrm>
+          <a:off x="0" y="0"/>
+          <a:ext cx="0" cy="0"/>
+          <a:chOff x="0" y="0"/>
+          <a:chExt cx="0" cy="0"/>
+        </a:xfrm>
+      </p:grpSpPr>
+      <p:sp>
+        <p:nvSpPr>
+          <p:cNvPr id="2" name="Slide Image Placeholder 1"/>
+          <p:cNvSpPr>
+            <a:spLocks noGrp="1"/>
+          </p:cNvSpPr>
+          <p:nvPr>
+            <p:ph type="sldImg" idx="2"/>
+          </p:nvPr>
+        </p:nvSpPr>
+        <p:spPr/>
+      </p:sp>
+      <p:sp>
+        <p:nvSpPr>
+          <p:cNvPr id="3" name="Notes Placeholder 2"/>
+          <p:cNvSpPr>
+            <a:spLocks noGrp="1"/>
+          </p:cNvSpPr>
+          <p:nvPr>
+            <p:ph type="body" idx="3" sz="quarter"/>
+          </p:nvPr>
+        </p:nvSpPr>
+        <p:spPr/>
+        <p:txBody>
+          <a:bodyPr/>
+          <a:lstStyle/>
+          <a:p>
+            <a:r>
+              <a:t>[7:30-8:00] Evidencias (30 s)</a:t>
+            </a:r>
+          </a:p>
+          <a:p>
+            <a:r>
+              <a:t>Aquí están las capturas del servidor SonarQube local. Se ven los dashboards de ambos proyectos, los issues de code smells y del frontend, el Quality Gate y el resumen de proyectos. Todas las capturas están incorporadas también en el Anexo E del informe, para que la evidencia sea verificable.</a:t>
+            </a:r>
+          </a:p>
+        </p:txBody>
+      </p:sp>
+      <p:sp>
+        <p:nvSpPr>
+          <p:cNvPr id="4" name="Slide Number Placeholder 3"/>
+          <p:cNvSpPr>
+            <a:spLocks noGrp="1"/>
+          </p:cNvSpPr>
+          <p:nvPr>
+            <p:ph type="sldNum" idx="5" sz="quarter"/>
+          </p:nvPr>
+        </p:nvSpPr>
+        <p:spPr/>
+      </p:sp>
+    </p:spTree>
+  </p:cSld>
+  <p:clrMapOvr>
+    <a:masterClrMapping/>
+  </p:clrMapOvr>
+</p:notes>
+</file>
+
+<file path=ppt/notesSlides/notesSlide12.xml><?xml version="1.0" encoding="utf-8"?>
+<p:notes xmlns:a="http://schemas.openxmlformats.org/drawingml/2006/main" xmlns:p="http://schemas.openxmlformats.org/presentationml/2006/main" xmlns:r="http://schemas.openxmlformats.org/officeDocument/2006/relationships">
+  <p:cSld>
+    <p:spTree>
+      <p:nvGrpSpPr>
+        <p:cNvPr id="1" name=""/>
+        <p:cNvGrpSpPr/>
+        <p:nvPr/>
+      </p:nvGrpSpPr>
+      <p:grpSpPr>
+        <a:xfrm>
+          <a:off x="0" y="0"/>
+          <a:ext cx="0" cy="0"/>
+          <a:chOff x="0" y="0"/>
+          <a:chExt cx="0" cy="0"/>
+        </a:xfrm>
+      </p:grpSpPr>
+      <p:sp>
+        <p:nvSpPr>
+          <p:cNvPr id="2" name="Slide Image Placeholder 1"/>
+          <p:cNvSpPr>
+            <a:spLocks noGrp="1"/>
+          </p:cNvSpPr>
+          <p:nvPr>
+            <p:ph type="sldImg" idx="2"/>
+          </p:nvPr>
+        </p:nvSpPr>
+        <p:spPr/>
+      </p:sp>
+      <p:sp>
+        <p:nvSpPr>
+          <p:cNvPr id="3" name="Notes Placeholder 2"/>
+          <p:cNvSpPr>
+            <a:spLocks noGrp="1"/>
+          </p:cNvSpPr>
+          <p:nvPr>
+            <p:ph type="body" idx="3" sz="quarter"/>
+          </p:nvPr>
+        </p:nvSpPr>
+        <p:spPr/>
+        <p:txBody>
+          <a:bodyPr/>
+          <a:lstStyle/>
+          <a:p>
+            <a:r>
+              <a:t>[8:00-9:00] Reflexiones (60 s)</a:t>
+            </a:r>
+          </a:p>
+          <a:p>
+            <a:r>
+              <a:t>En calidad, el sistema tiene una base funcional correcta, pero una deuda técnica alta en el frontend y un bug de compatibilidad con React 19. En seguridad, los cuatro defectos críticos se mapean a OWASP: control de acceso roto, fallas criptográficas, fallas de autenticación y de integridad de datos y software.</a:t>
+            </a:r>
+          </a:p>
+          <a:p>
+            <a:r>
+              <a:t>En lo normativo, la exposición de datos personales y el manejo de contraseñas incumplen la Ley 19.628 y la 21.719, y los controles de acceso y criptografía de ISO 27001. En lo legal, los datos de clientes no pueden quedar accesibles sin autorización. Y en lo ético, nuestro compromiso fue reportar todo con transparencia y evidencia, sin ocultar hallazgos y sin usar datos reales.</a:t>
+            </a:r>
+          </a:p>
+        </p:txBody>
+      </p:sp>
+      <p:sp>
+        <p:nvSpPr>
+          <p:cNvPr id="4" name="Slide Number Placeholder 3"/>
+          <p:cNvSpPr>
+            <a:spLocks noGrp="1"/>
+          </p:cNvSpPr>
+          <p:nvPr>
+            <p:ph type="sldNum" idx="5" sz="quarter"/>
+          </p:nvPr>
+        </p:nvSpPr>
+        <p:spPr/>
+      </p:sp>
+    </p:spTree>
+  </p:cSld>
+  <p:clrMapOvr>
+    <a:masterClrMapping/>
+  </p:clrMapOvr>
+</p:notes>
+</file>
+
+<file path=ppt/notesSlides/notesSlide13.xml><?xml version="1.0" encoding="utf-8"?>
+<p:notes xmlns:a="http://schemas.openxmlformats.org/drawingml/2006/main" xmlns:p="http://schemas.openxmlformats.org/presentationml/2006/main" xmlns:r="http://schemas.openxmlformats.org/officeDocument/2006/relationships">
+  <p:cSld>
+    <p:spTree>
+      <p:nvGrpSpPr>
+        <p:cNvPr id="1" name=""/>
+        <p:cNvGrpSpPr/>
+        <p:nvPr/>
+      </p:nvGrpSpPr>
+      <p:grpSpPr>
+        <a:xfrm>
+          <a:off x="0" y="0"/>
+          <a:ext cx="0" cy="0"/>
+          <a:chOff x="0" y="0"/>
+          <a:chExt cx="0" cy="0"/>
+        </a:xfrm>
+      </p:grpSpPr>
+      <p:sp>
+        <p:nvSpPr>
+          <p:cNvPr id="2" name="Slide Image Placeholder 1"/>
+          <p:cNvSpPr>
+            <a:spLocks noGrp="1"/>
+          </p:cNvSpPr>
+          <p:nvPr>
+            <p:ph type="sldImg" idx="2"/>
+          </p:nvPr>
+        </p:nvSpPr>
+        <p:spPr/>
+      </p:sp>
+      <p:sp>
+        <p:nvSpPr>
+          <p:cNvPr id="3" name="Notes Placeholder 2"/>
+          <p:cNvSpPr>
+            <a:spLocks noGrp="1"/>
+          </p:cNvSpPr>
+          <p:nvPr>
+            <p:ph type="body" idx="3" sz="quarter"/>
+          </p:nvPr>
+        </p:nvSpPr>
+        <p:spPr/>
+        <p:txBody>
+          <a:bodyPr/>
+          <a:lstStyle/>
+          <a:p>
+            <a:r>
+              <a:t>[9:00-9:40] Dictamen (40 s)</a:t>
+            </a:r>
+          </a:p>
+          <a:p>
+            <a:r>
+              <a:t>El criterio de certificación era tener el 100 % de los casos de seguridad críticos exitosos y ningún defecto crítico abierto. No se cumplió: fallaron CP-010 y CP-011 y quedan 4 incidentes CRITICO. Por eso el dictamen es NO CERTIFICADO. Las acciones correctivas prioritarias son: autenticación global en todos los endpoints, hash seguro de contraseñas, validación de archivos, secretos fuera del código, CORS restringido, rate-limit, transacciones y errores genéricos, cookies httpOnly y un Quality Gate de seguridad en CI.</a:t>
+            </a:r>
+          </a:p>
+        </p:txBody>
+      </p:sp>
+      <p:sp>
+        <p:nvSpPr>
+          <p:cNvPr id="4" name="Slide Number Placeholder 3"/>
+          <p:cNvSpPr>
+            <a:spLocks noGrp="1"/>
+          </p:cNvSpPr>
+          <p:nvPr>
+            <p:ph type="sldNum" idx="5" sz="quarter"/>
+          </p:nvPr>
+        </p:nvSpPr>
+        <p:spPr/>
+      </p:sp>
+    </p:spTree>
+  </p:cSld>
+  <p:clrMapOvr>
+    <a:masterClrMapping/>
+  </p:clrMapOvr>
+</p:notes>
+</file>
+
+<file path=ppt/notesSlides/notesSlide14.xml><?xml version="1.0" encoding="utf-8"?>
+<p:notes xmlns:a="http://schemas.openxmlformats.org/drawingml/2006/main" xmlns:p="http://schemas.openxmlformats.org/presentationml/2006/main" xmlns:r="http://schemas.openxmlformats.org/officeDocument/2006/relationships">
+  <p:cSld>
+    <p:spTree>
+      <p:nvGrpSpPr>
+        <p:cNvPr id="1" name=""/>
+        <p:cNvGrpSpPr/>
+        <p:nvPr/>
+      </p:nvGrpSpPr>
+      <p:grpSpPr>
+        <a:xfrm>
+          <a:off x="0" y="0"/>
+          <a:ext cx="0" cy="0"/>
+          <a:chOff x="0" y="0"/>
+          <a:chExt cx="0" cy="0"/>
+        </a:xfrm>
+      </p:grpSpPr>
+      <p:sp>
+        <p:nvSpPr>
+          <p:cNvPr id="2" name="Slide Image Placeholder 1"/>
+          <p:cNvSpPr>
+            <a:spLocks noGrp="1"/>
+          </p:cNvSpPr>
+          <p:nvPr>
+            <p:ph type="sldImg" idx="2"/>
+          </p:nvPr>
+        </p:nvSpPr>
+        <p:spPr/>
+      </p:sp>
+      <p:sp>
+        <p:nvSpPr>
+          <p:cNvPr id="3" name="Notes Placeholder 2"/>
+          <p:cNvSpPr>
+            <a:spLocks noGrp="1"/>
+          </p:cNvSpPr>
+          <p:nvPr>
+            <p:ph type="body" idx="3" sz="quarter"/>
+          </p:nvPr>
+        </p:nvSpPr>
+        <p:spPr/>
+        <p:txBody>
+          <a:bodyPr/>
+          <a:lstStyle/>
+          <a:p>
+            <a:r>
+              <a:t>[9:40-10:00] Cierre (20 s)</a:t>
+            </a:r>
+          </a:p>
+          <a:p>
+            <a:r>
+              <a:t>Con esto cerramos la presentación. El informe completo, con el detalle de cada caso y las evidencias, está disponible como respaldo. Quedamos atentos a sus preguntas.</a:t>
+            </a:r>
+          </a:p>
+        </p:txBody>
+      </p:sp>
+      <p:sp>
+        <p:nvSpPr>
+          <p:cNvPr id="4" name="Slide Number Placeholder 3"/>
+          <p:cNvSpPr>
+            <a:spLocks noGrp="1"/>
+          </p:cNvSpPr>
+          <p:nvPr>
+            <p:ph type="sldNum" idx="5" sz="quarter"/>
+          </p:nvPr>
+        </p:nvSpPr>
+        <p:spPr/>
+      </p:sp>
+    </p:spTree>
+  </p:cSld>
+  <p:clrMapOvr>
+    <a:masterClrMapping/>
+  </p:clrMapOvr>
+</p:notes>
+</file>
+
+<file path=ppt/notesSlides/notesSlide2.xml><?xml version="1.0" encoding="utf-8"?>
+<p:notes xmlns:a="http://schemas.openxmlformats.org/drawingml/2006/main" xmlns:p="http://schemas.openxmlformats.org/presentationml/2006/main" xmlns:r="http://schemas.openxmlformats.org/officeDocument/2006/relationships">
+  <p:cSld>
+    <p:spTree>
+      <p:nvGrpSpPr>
+        <p:cNvPr id="1" name=""/>
+        <p:cNvGrpSpPr/>
+        <p:nvPr/>
+      </p:nvGrpSpPr>
+      <p:grpSpPr>
+        <a:xfrm>
+          <a:off x="0" y="0"/>
+          <a:ext cx="0" cy="0"/>
+          <a:chOff x="0" y="0"/>
+          <a:chExt cx="0" cy="0"/>
+        </a:xfrm>
+      </p:grpSpPr>
+      <p:sp>
+        <p:nvSpPr>
+          <p:cNvPr id="2" name="Slide Image Placeholder 1"/>
+          <p:cNvSpPr>
+            <a:spLocks noGrp="1"/>
+          </p:cNvSpPr>
+          <p:nvPr>
+            <p:ph type="sldImg" idx="2"/>
+          </p:nvPr>
+        </p:nvSpPr>
+        <p:spPr/>
+      </p:sp>
+      <p:sp>
+        <p:nvSpPr>
+          <p:cNvPr id="3" name="Notes Placeholder 2"/>
+          <p:cNvSpPr>
+            <a:spLocks noGrp="1"/>
+          </p:cNvSpPr>
+          <p:nvPr>
+            <p:ph type="body" idx="3" sz="quarter"/>
+          </p:nvPr>
+        </p:nvSpPr>
+        <p:spPr/>
+        <p:txBody>
+          <a:bodyPr/>
+          <a:lstStyle/>
+          <a:p>
+            <a:r>
+              <a:t>[0:30-0:50] Contenido (20 s)</a:t>
+            </a:r>
+          </a:p>
+          <a:p>
+            <a:r>
+              <a:t>La presentación sigue el orden exigido: contexto y alcance, enfoque estratégico de las pruebas, tipos y herramientas, resultados de ejecución, análisis estático, clasificación de los defectos, reflexiones de calidad, seguridad y normativa, y finalmente el dictamen con las acciones correctivas.</a:t>
+            </a:r>
+          </a:p>
+        </p:txBody>
+      </p:sp>
+      <p:sp>
+        <p:nvSpPr>
+          <p:cNvPr id="4" name="Slide Number Placeholder 3"/>
+          <p:cNvSpPr>
+            <a:spLocks noGrp="1"/>
+          </p:cNvSpPr>
+          <p:nvPr>
+            <p:ph type="sldNum" idx="5" sz="quarter"/>
+          </p:nvPr>
+        </p:nvSpPr>
+        <p:spPr/>
+      </p:sp>
+    </p:spTree>
+  </p:cSld>
+  <p:clrMapOvr>
+    <a:masterClrMapping/>
+  </p:clrMapOvr>
+</p:notes>
+</file>
+
+<file path=ppt/notesSlides/notesSlide3.xml><?xml version="1.0" encoding="utf-8"?>
+<p:notes xmlns:a="http://schemas.openxmlformats.org/drawingml/2006/main" xmlns:p="http://schemas.openxmlformats.org/presentationml/2006/main" xmlns:r="http://schemas.openxmlformats.org/officeDocument/2006/relationships">
+  <p:cSld>
+    <p:spTree>
+      <p:nvGrpSpPr>
+        <p:cNvPr id="1" name=""/>
+        <p:cNvGrpSpPr/>
+        <p:nvPr/>
+      </p:nvGrpSpPr>
+      <p:grpSpPr>
+        <a:xfrm>
+          <a:off x="0" y="0"/>
+          <a:ext cx="0" cy="0"/>
+          <a:chOff x="0" y="0"/>
+          <a:chExt cx="0" cy="0"/>
+        </a:xfrm>
+      </p:grpSpPr>
+      <p:sp>
+        <p:nvSpPr>
+          <p:cNvPr id="2" name="Slide Image Placeholder 1"/>
+          <p:cNvSpPr>
+            <a:spLocks noGrp="1"/>
+          </p:cNvSpPr>
+          <p:nvPr>
+            <p:ph type="sldImg" idx="2"/>
+          </p:nvPr>
+        </p:nvSpPr>
+        <p:spPr/>
+      </p:sp>
+      <p:sp>
+        <p:nvSpPr>
+          <p:cNvPr id="3" name="Notes Placeholder 2"/>
+          <p:cNvSpPr>
+            <a:spLocks noGrp="1"/>
+          </p:cNvSpPr>
+          <p:nvPr>
+            <p:ph type="body" idx="3" sz="quarter"/>
+          </p:nvPr>
+        </p:nvSpPr>
+        <p:spPr/>
+        <p:txBody>
+          <a:bodyPr/>
+          <a:lstStyle/>
+          <a:p>
+            <a:r>
+              <a:t>[0:50-1:40] Contexto y alcance (50 s)</a:t>
+            </a:r>
+          </a:p>
+          <a:p>
+            <a:r>
+              <a:t>Atlas es una plataforma web para pymes chilenas que gestiona clientes, contratos y documentos. Tiene arquitectura de tres capas: frontend React con Material UI, API REST en Express/Node y PostgreSQL. Evaluamos seis módulos: autenticación, clientes, contratos y documentos, usuarios y roles, métricas y auditoría.</a:t>
+            </a:r>
+          </a:p>
+          <a:p>
+            <a:r>
+              <a:t>Nos guiamos por ISO/IEC 25010 para calidad, ISO/IEC 27001 y OWASP Top 10 para seguridad, y la Ley 19.628 y 21.719 de protección de datos. El objetivo era determinar con evidencia si el software es apto para producción. Todo se ejecutó sobre un despliegue Docker en laboratorio: frontend en el puerto 3350, API en 4450 y PostgreSQL en 15432.</a:t>
+            </a:r>
+          </a:p>
+        </p:txBody>
+      </p:sp>
+      <p:sp>
+        <p:nvSpPr>
+          <p:cNvPr id="4" name="Slide Number Placeholder 3"/>
+          <p:cNvSpPr>
+            <a:spLocks noGrp="1"/>
+          </p:cNvSpPr>
+          <p:nvPr>
+            <p:ph type="sldNum" idx="5" sz="quarter"/>
+          </p:nvPr>
+        </p:nvSpPr>
+        <p:spPr/>
+      </p:sp>
+    </p:spTree>
+  </p:cSld>
+  <p:clrMapOvr>
+    <a:masterClrMapping/>
+  </p:clrMapOvr>
+</p:notes>
+</file>
+
+<file path=ppt/notesSlides/notesSlide4.xml><?xml version="1.0" encoding="utf-8"?>
+<p:notes xmlns:a="http://schemas.openxmlformats.org/drawingml/2006/main" xmlns:p="http://schemas.openxmlformats.org/presentationml/2006/main" xmlns:r="http://schemas.openxmlformats.org/officeDocument/2006/relationships">
+  <p:cSld>
+    <p:spTree>
+      <p:nvGrpSpPr>
+        <p:cNvPr id="1" name=""/>
+        <p:cNvGrpSpPr/>
+        <p:nvPr/>
+      </p:nvGrpSpPr>
+      <p:grpSpPr>
+        <a:xfrm>
+          <a:off x="0" y="0"/>
+          <a:ext cx="0" cy="0"/>
+          <a:chOff x="0" y="0"/>
+          <a:chExt cx="0" cy="0"/>
+        </a:xfrm>
+      </p:grpSpPr>
+      <p:sp>
+        <p:nvSpPr>
+          <p:cNvPr id="2" name="Slide Image Placeholder 1"/>
+          <p:cNvSpPr>
+            <a:spLocks noGrp="1"/>
+          </p:cNvSpPr>
+          <p:nvPr>
+            <p:ph type="sldImg" idx="2"/>
+          </p:nvPr>
+        </p:nvSpPr>
+        <p:spPr/>
+      </p:sp>
+      <p:sp>
+        <p:nvSpPr>
+          <p:cNvPr id="3" name="Notes Placeholder 2"/>
+          <p:cNvSpPr>
+            <a:spLocks noGrp="1"/>
+          </p:cNvSpPr>
+          <p:nvPr>
+            <p:ph type="body" idx="3" sz="quarter"/>
+          </p:nvPr>
+        </p:nvSpPr>
+        <p:spPr/>
+        <p:txBody>
+          <a:bodyPr/>
+          <a:lstStyle/>
+          <a:p>
+            <a:r>
+              <a:t>[1:40-2:40] Enfoque estratégico (60 s)</a:t>
+            </a:r>
+          </a:p>
+          <a:p>
+            <a:r>
+              <a:t>Aplicamos un enfoque mixto: ejecución manual reproducible con curl, análisis estático automatizado y revisión manual del código. La priorización fue por riesgo: primero seguridad —control de acceso, subida de archivos e inyección—, luego la funcionalidad central y al final lo no funcional.</a:t>
+            </a:r>
+          </a:p>
+          <a:p>
+            <a:r>
+              <a:t>Trabajamos en dos ciclos: el Ciclo 1 fue un smoke test de funciones base; si fallaba, deteníamos la ejecución. El Ciclo 2 ejecutó 12 casos funcionales y de seguridad más pruebas complementarias. Los criterios de entrada exigían entorno desplegado, datos semilla y casos revisados; los de salida, el 100 % de los casos críticos ejecutados, sin defectos críticos abiertos y con evidencia registrada.</a:t>
+            </a:r>
+          </a:p>
+        </p:txBody>
+      </p:sp>
+      <p:sp>
+        <p:nvSpPr>
+          <p:cNvPr id="4" name="Slide Number Placeholder 3"/>
+          <p:cNvSpPr>
+            <a:spLocks noGrp="1"/>
+          </p:cNvSpPr>
+          <p:nvPr>
+            <p:ph type="sldNum" idx="5" sz="quarter"/>
+          </p:nvPr>
+        </p:nvSpPr>
+        <p:spPr/>
+      </p:sp>
+    </p:spTree>
+  </p:cSld>
+  <p:clrMapOvr>
+    <a:masterClrMapping/>
+  </p:clrMapOvr>
+</p:notes>
+</file>
+
+<file path=ppt/notesSlides/notesSlide5.xml><?xml version="1.0" encoding="utf-8"?>
+<p:notes xmlns:a="http://schemas.openxmlformats.org/drawingml/2006/main" xmlns:p="http://schemas.openxmlformats.org/presentationml/2006/main" xmlns:r="http://schemas.openxmlformats.org/officeDocument/2006/relationships">
+  <p:cSld>
+    <p:spTree>
+      <p:nvGrpSpPr>
+        <p:cNvPr id="1" name=""/>
+        <p:cNvGrpSpPr/>
+        <p:nvPr/>
+      </p:nvGrpSpPr>
+      <p:grpSpPr>
+        <a:xfrm>
+          <a:off x="0" y="0"/>
+          <a:ext cx="0" cy="0"/>
+          <a:chOff x="0" y="0"/>
+          <a:chExt cx="0" cy="0"/>
+        </a:xfrm>
+      </p:grpSpPr>
+      <p:sp>
+        <p:nvSpPr>
+          <p:cNvPr id="2" name="Slide Image Placeholder 1"/>
+          <p:cNvSpPr>
+            <a:spLocks noGrp="1"/>
+          </p:cNvSpPr>
+          <p:nvPr>
+            <p:ph type="sldImg" idx="2"/>
+          </p:nvPr>
+        </p:nvSpPr>
+        <p:spPr/>
+      </p:sp>
+      <p:sp>
+        <p:nvSpPr>
+          <p:cNvPr id="3" name="Notes Placeholder 2"/>
+          <p:cNvSpPr>
+            <a:spLocks noGrp="1"/>
+          </p:cNvSpPr>
+          <p:nvPr>
+            <p:ph type="body" idx="3" sz="quarter"/>
+          </p:nvPr>
+        </p:nvSpPr>
+        <p:spPr/>
+        <p:txBody>
+          <a:bodyPr/>
+          <a:lstStyle/>
+          <a:p>
+            <a:r>
+              <a:t>[2:40-3:20] Tipos de prueba (40 s)</a:t>
+            </a:r>
+          </a:p>
+          <a:p>
+            <a:r>
+              <a:t>Diseñamos cinco tipos de prueba, cada uno justificado por el ERS. Funcionales para validar los requisitos RF-1 a RF-6: login, CRUD de clientes, contratos, usuarios, dashboard y auditoría. De seguridad para control de acceso, uploads, SQLi, CORS y fuerza bruta. De integración para verificar el flujo completo entre frontend, API y base de datos. De rendimiento para comparar los tiempos de respuesta con los umbrales NFR-PERF. Y de usabilidad, en una revisión acotada de los estados de interfaz.</a:t>
+            </a:r>
+          </a:p>
+        </p:txBody>
+      </p:sp>
+      <p:sp>
+        <p:nvSpPr>
+          <p:cNvPr id="4" name="Slide Number Placeholder 3"/>
+          <p:cNvSpPr>
+            <a:spLocks noGrp="1"/>
+          </p:cNvSpPr>
+          <p:nvPr>
+            <p:ph type="sldNum" idx="5" sz="quarter"/>
+          </p:nvPr>
+        </p:nvSpPr>
+        <p:spPr/>
+      </p:sp>
+    </p:spTree>
+  </p:cSld>
+  <p:clrMapOvr>
+    <a:masterClrMapping/>
+  </p:clrMapOvr>
+</p:notes>
+</file>
+
+<file path=ppt/notesSlides/notesSlide6.xml><?xml version="1.0" encoding="utf-8"?>
+<p:notes xmlns:a="http://schemas.openxmlformats.org/drawingml/2006/main" xmlns:p="http://schemas.openxmlformats.org/presentationml/2006/main" xmlns:r="http://schemas.openxmlformats.org/officeDocument/2006/relationships">
+  <p:cSld>
+    <p:spTree>
+      <p:nvGrpSpPr>
+        <p:cNvPr id="1" name=""/>
+        <p:cNvGrpSpPr/>
+        <p:nvPr/>
+      </p:nvGrpSpPr>
+      <p:grpSpPr>
+        <a:xfrm>
+          <a:off x="0" y="0"/>
+          <a:ext cx="0" cy="0"/>
+          <a:chOff x="0" y="0"/>
+          <a:chExt cx="0" cy="0"/>
+        </a:xfrm>
+      </p:grpSpPr>
+      <p:sp>
+        <p:nvSpPr>
+          <p:cNvPr id="2" name="Slide Image Placeholder 1"/>
+          <p:cNvSpPr>
+            <a:spLocks noGrp="1"/>
+          </p:cNvSpPr>
+          <p:nvPr>
+            <p:ph type="sldImg" idx="2"/>
+          </p:nvPr>
+        </p:nvSpPr>
+        <p:spPr/>
+      </p:sp>
+      <p:sp>
+        <p:nvSpPr>
+          <p:cNvPr id="3" name="Notes Placeholder 2"/>
+          <p:cNvSpPr>
+            <a:spLocks noGrp="1"/>
+          </p:cNvSpPr>
+          <p:nvPr>
+            <p:ph type="body" idx="3" sz="quarter"/>
+          </p:nvPr>
+        </p:nvSpPr>
+        <p:spPr/>
+        <p:txBody>
+          <a:bodyPr/>
+          <a:lstStyle/>
+          <a:p>
+            <a:r>
+              <a:t>[3:20-4:10] Herramientas (50 s)</a:t>
+            </a:r>
+          </a:p>
+          <a:p>
+            <a:r>
+              <a:t>Elegimos cada herramienta por su aporte a la evidencia. Docker Compose reproduce el ambiente completo de forma aislada y verificable. curl nos permite controlar token, cabeceras y payloads, y registrar el código HTTP como prueba. ESLint detecta errores y malas prácticas de calidad de forma automática. SonarQube entrega métricas objetivas de bugs, vulnerabilidades, hotspots y duplicación. Y la revisión manual cubre lo que las herramientas no ven: control de acceso, secretos y manejo de archivos. El equipo de prueba fue un líder de QA, un tester funcional y un tester de seguridad, sobre un entorno QA local con datos ficticios.</a:t>
+            </a:r>
+          </a:p>
+        </p:txBody>
+      </p:sp>
+      <p:sp>
+        <p:nvSpPr>
+          <p:cNvPr id="4" name="Slide Number Placeholder 3"/>
+          <p:cNvSpPr>
+            <a:spLocks noGrp="1"/>
+          </p:cNvSpPr>
+          <p:nvPr>
+            <p:ph type="sldNum" idx="5" sz="quarter"/>
+          </p:nvPr>
+        </p:nvSpPr>
+        <p:spPr/>
+      </p:sp>
+    </p:spTree>
+  </p:cSld>
+  <p:clrMapOvr>
+    <a:masterClrMapping/>
+  </p:clrMapOvr>
+</p:notes>
+</file>
+
+<file path=ppt/notesSlides/notesSlide7.xml><?xml version="1.0" encoding="utf-8"?>
+<p:notes xmlns:a="http://schemas.openxmlformats.org/drawingml/2006/main" xmlns:p="http://schemas.openxmlformats.org/presentationml/2006/main" xmlns:r="http://schemas.openxmlformats.org/officeDocument/2006/relationships">
+  <p:cSld>
+    <p:spTree>
+      <p:nvGrpSpPr>
+        <p:cNvPr id="1" name=""/>
+        <p:cNvGrpSpPr/>
+        <p:nvPr/>
+      </p:nvGrpSpPr>
+      <p:grpSpPr>
+        <a:xfrm>
+          <a:off x="0" y="0"/>
+          <a:ext cx="0" cy="0"/>
+          <a:chOff x="0" y="0"/>
+          <a:chExt cx="0" cy="0"/>
+        </a:xfrm>
+      </p:grpSpPr>
+      <p:sp>
+        <p:nvSpPr>
+          <p:cNvPr id="2" name="Slide Image Placeholder 1"/>
+          <p:cNvSpPr>
+            <a:spLocks noGrp="1"/>
+          </p:cNvSpPr>
+          <p:nvPr>
+            <p:ph type="sldImg" idx="2"/>
+          </p:nvPr>
+        </p:nvSpPr>
+        <p:spPr/>
+      </p:sp>
+      <p:sp>
+        <p:nvSpPr>
+          <p:cNvPr id="3" name="Notes Placeholder 2"/>
+          <p:cNvSpPr>
+            <a:spLocks noGrp="1"/>
+          </p:cNvSpPr>
+          <p:nvPr>
+            <p:ph type="body" idx="3" sz="quarter"/>
+          </p:nvPr>
+        </p:nvSpPr>
+        <p:spPr/>
+        <p:txBody>
+          <a:bodyPr/>
+          <a:lstStyle/>
+          <a:p>
+            <a:r>
+              <a:t>[4:10-5:00] Resumen de ejecución (50 s)</a:t>
+            </a:r>
+          </a:p>
+          <a:p>
+            <a:r>
+              <a:t>Diseñamos y ejecutamos 12 casos: 10 aprobados, un 83 % de éxito, y 2 fallidos. Los fallos son CP-010, que aceptó un archivo ejecutable en la subida de documentos, y CP-011, que permitió leer datos de contratos sin token. Sumamos 10 pruebas de seguridad complementarias, de las cuales 7 arrojaron resultado inseguro. En total registramos 11 incidentes: 4 críticos, 5 graves, 1 moderado y 1 leve. ESLint reportó 14 problemas y SonarQube, 1 vulnerabilidad BLOCKER, 4 hotspots y 198 code smells. El tiempo de respuesta fue de 4 segundos por una latencia artificial en el código.</a:t>
+            </a:r>
+          </a:p>
+        </p:txBody>
+      </p:sp>
+      <p:sp>
+        <p:nvSpPr>
+          <p:cNvPr id="4" name="Slide Number Placeholder 3"/>
+          <p:cNvSpPr>
+            <a:spLocks noGrp="1"/>
+          </p:cNvSpPr>
+          <p:nvPr>
+            <p:ph type="sldNum" idx="5" sz="quarter"/>
+          </p:nvPr>
+        </p:nvSpPr>
+        <p:spPr/>
+      </p:sp>
+    </p:spTree>
+  </p:cSld>
+  <p:clrMapOvr>
+    <a:masterClrMapping/>
+  </p:clrMapOvr>
+</p:notes>
+</file>
+
+<file path=ppt/notesSlides/notesSlide8.xml><?xml version="1.0" encoding="utf-8"?>
+<p:notes xmlns:a="http://schemas.openxmlformats.org/drawingml/2006/main" xmlns:p="http://schemas.openxmlformats.org/presentationml/2006/main" xmlns:r="http://schemas.openxmlformats.org/officeDocument/2006/relationships">
+  <p:cSld>
+    <p:spTree>
+      <p:nvGrpSpPr>
+        <p:cNvPr id="1" name=""/>
+        <p:cNvGrpSpPr/>
+        <p:nvPr/>
+      </p:nvGrpSpPr>
+      <p:grpSpPr>
+        <a:xfrm>
+          <a:off x="0" y="0"/>
+          <a:ext cx="0" cy="0"/>
+          <a:chOff x="0" y="0"/>
+          <a:chExt cx="0" cy="0"/>
+        </a:xfrm>
+      </p:grpSpPr>
+      <p:sp>
+        <p:nvSpPr>
+          <p:cNvPr id="2" name="Slide Image Placeholder 1"/>
+          <p:cNvSpPr>
+            <a:spLocks noGrp="1"/>
+          </p:cNvSpPr>
+          <p:nvPr>
+            <p:ph type="sldImg" idx="2"/>
+          </p:nvPr>
+        </p:nvSpPr>
+        <p:spPr/>
+      </p:sp>
+      <p:sp>
+        <p:nvSpPr>
+          <p:cNvPr id="3" name="Notes Placeholder 2"/>
+          <p:cNvSpPr>
+            <a:spLocks noGrp="1"/>
+          </p:cNvSpPr>
+          <p:nvPr>
+            <p:ph type="body" idx="3" sz="quarter"/>
+          </p:nvPr>
+        </p:nvSpPr>
+        <p:spPr/>
+        <p:txBody>
+          <a:bodyPr/>
+          <a:lstStyle/>
+          <a:p>
+            <a:r>
+              <a:t>[5:00-5:50] Casos representativos (50 s)</a:t>
+            </a:r>
+          </a:p>
+          <a:p>
+            <a:r>
+              <a:t>Estos son los casos que mejor resumen el resultado. CP-001 aprobó: el login válido emite el JWT. CP-010 falló: el sistema aceptó un archivo .exe y lo sirvió como PDF, lo que es un riesgo de malware. CP-011 falló: un GET a contratos sin token devolvió los datos completos, un IDOR clásico. CP-012 sí aprobó: el intento de inyección SQL fue rechazado con 401 porque las consultas están parametrizadas. SEG-12 mostró CORS abierto con Allow-Origin asterisco, y FN-02 midió 4,06 segundos frente a un umbral de 300 milisegundos.</a:t>
+            </a:r>
+          </a:p>
+        </p:txBody>
+      </p:sp>
+      <p:sp>
+        <p:nvSpPr>
+          <p:cNvPr id="4" name="Slide Number Placeholder 3"/>
+          <p:cNvSpPr>
+            <a:spLocks noGrp="1"/>
+          </p:cNvSpPr>
+          <p:nvPr>
+            <p:ph type="sldNum" idx="5" sz="quarter"/>
+          </p:nvPr>
+        </p:nvSpPr>
+        <p:spPr/>
+      </p:sp>
+    </p:spTree>
+  </p:cSld>
+  <p:clrMapOvr>
+    <a:masterClrMapping/>
+  </p:clrMapOvr>
+</p:notes>
+</file>
+
+<file path=ppt/notesSlides/notesSlide9.xml><?xml version="1.0" encoding="utf-8"?>
+<p:notes xmlns:a="http://schemas.openxmlformats.org/drawingml/2006/main" xmlns:p="http://schemas.openxmlformats.org/presentationml/2006/main" xmlns:r="http://schemas.openxmlformats.org/officeDocument/2006/relationships">
+  <p:cSld>
+    <p:spTree>
+      <p:nvGrpSpPr>
+        <p:cNvPr id="1" name=""/>
+        <p:cNvGrpSpPr/>
+        <p:nvPr/>
+      </p:nvGrpSpPr>
+      <p:grpSpPr>
+        <a:xfrm>
+          <a:off x="0" y="0"/>
+          <a:ext cx="0" cy="0"/>
+          <a:chOff x="0" y="0"/>
+          <a:chExt cx="0" cy="0"/>
+        </a:xfrm>
+      </p:grpSpPr>
+      <p:sp>
+        <p:nvSpPr>
+          <p:cNvPr id="2" name="Slide Image Placeholder 1"/>
+          <p:cNvSpPr>
+            <a:spLocks noGrp="1"/>
+          </p:cNvSpPr>
+          <p:nvPr>
+            <p:ph type="sldImg" idx="2"/>
+          </p:nvPr>
+        </p:nvSpPr>
+        <p:spPr/>
+      </p:sp>
+      <p:sp>
+        <p:nvSpPr>
+          <p:cNvPr id="3" name="Notes Placeholder 2"/>
+          <p:cNvSpPr>
+            <a:spLocks noGrp="1"/>
+          </p:cNvSpPr>
+          <p:nvPr>
+            <p:ph type="body" idx="3" sz="quarter"/>
+          </p:nvPr>
+        </p:nvSpPr>
+        <p:spPr/>
+        <p:txBody>
+          <a:bodyPr/>
+          <a:lstStyle/>
+          <a:p>
+            <a:r>
+              <a:t>[5:50-6:40] Análisis estático (50 s)</a:t>
+            </a:r>
+          </a:p>
+          <a:p>
+            <a:r>
+              <a:t>El análisis estático confirma lo que vimos dinámicamente. ESLint detectó 14 problemas, principalmente variables e imports sin uso y dependencias de hooks. SonarQube, en el backend, encontró una vulnerabilidad BLOCKER: la contraseña de PostgreSQL escrita directamente en db.js, línea 6. Además, 4 security hotspots y un Security Rating E. En el frontend encontró 1 bug, 181 code smells y un problema crítico de complejidad cognitiva. Lo relevante es que los hotspots coinciden exactamente con los defectos BUG-003, de subida de archivos, y BUG-005, de CORS.</a:t>
+            </a:r>
+          </a:p>
+        </p:txBody>
+      </p:sp>
+      <p:sp>
+        <p:nvSpPr>
+          <p:cNvPr id="4" name="Slide Number Placeholder 3"/>
+          <p:cNvSpPr>
+            <a:spLocks noGrp="1"/>
+          </p:cNvSpPr>
+          <p:nvPr>
+            <p:ph type="sldNum" idx="5" sz="quarter"/>
+          </p:nvPr>
+        </p:nvSpPr>
+        <p:spPr/>
+      </p:sp>
+    </p:spTree>
+  </p:cSld>
+  <p:clrMapOvr>
+    <a:masterClrMapping/>
+  </p:clrMapOvr>
+</p:notes>
 </file>
 
 <file path=ppt/slideLayouts/slideLayout1.xml><?xml version="1.0" encoding="utf-8"?>
@@ -10089,4 +11504,324 @@
   </a:objectDefaults>
   <a:extraClrSchemeLst/>
 </a:theme>
+</file>
+
+<file path=ppt/theme/theme2.xml><?xml version="1.0" encoding="utf-8"?>
+<a:theme xmlns:a="http://schemas.openxmlformats.org/drawingml/2006/main" name="Office Theme">
+  <a:themeElements>
+    <a:clrScheme name="Office">
+      <a:dk1>
+        <a:sysClr val="windowText" lastClr="000000"/>
+      </a:dk1>
+      <a:lt1>
+        <a:sysClr val="window" lastClr="FFFFFF"/>
+      </a:lt1>
+      <a:dk2>
+        <a:srgbClr val="1F497D"/>
+      </a:dk2>
+      <a:lt2>
+        <a:srgbClr val="EEECE1"/>
+      </a:lt2>
+      <a:accent1>
+        <a:srgbClr val="4F81BD"/>
+      </a:accent1>
+      <a:accent2>
+        <a:srgbClr val="C0504D"/>
+      </a:accent2>
+      <a:accent3>
+        <a:srgbClr val="9BBB59"/>
+      </a:accent3>
+      <a:accent4>
+        <a:srgbClr val="8064A2"/>
+      </a:accent4>
+      <a:accent5>
+        <a:srgbClr val="4BACC6"/>
+      </a:accent5>
+      <a:accent6>
+        <a:srgbClr val="F79646"/>
+      </a:accent6>
+      <a:hlink>
+        <a:srgbClr val="0000FF"/>
+      </a:hlink>
+      <a:folHlink>
+        <a:srgbClr val="800080"/>
+      </a:folHlink>
+    </a:clrScheme>
+    <a:fontScheme name="Office">
+      <a:majorFont>
+        <a:latin typeface="Calibri"/>
+        <a:ea typeface=""/>
+        <a:cs typeface=""/>
+        <a:font script="Jpan" typeface="ＭＳ Ｐゴシック"/>
+        <a:font script="Hang" typeface="맑은 고딕"/>
+        <a:font script="Hans" typeface="宋体"/>
+        <a:font script="Hant" typeface="新細明體"/>
+        <a:font script="Arab" typeface="Times New Roman"/>
+        <a:font script="Hebr" typeface="Times New Roman"/>
+        <a:font script="Thai" typeface="Angsana New"/>
+        <a:font script="Ethi" typeface="Nyala"/>
+        <a:font script="Beng" typeface="Vrinda"/>
+        <a:font script="Gujr" typeface="Shruti"/>
+        <a:font script="Khmr" typeface="MoolBoran"/>
+        <a:font script="Knda" typeface="Tunga"/>
+        <a:font script="Guru" typeface="Raavi"/>
+        <a:font script="Cans" typeface="Euphemia"/>
+        <a:font script="Cher" typeface="Plantagenet Cherokee"/>
+        <a:font script="Yiii" typeface="Microsoft Yi Baiti"/>
+        <a:font script="Tibt" typeface="Microsoft Himalaya"/>
+        <a:font script="Thaa" typeface="MV Boli"/>
+        <a:font script="Deva" typeface="Mangal"/>
+        <a:font script="Telu" typeface="Gautami"/>
+        <a:font script="Taml" typeface="Latha"/>
+        <a:font script="Syrc" typeface="Estrangelo Edessa"/>
+        <a:font script="Orya" typeface="Kalinga"/>
+        <a:font script="Mlym" typeface="Kartika"/>
+        <a:font script="Laoo" typeface="DokChampa"/>
+        <a:font script="Sinh" typeface="Iskoola Pota"/>
+        <a:font script="Mong" typeface="Mongolian Baiti"/>
+        <a:font script="Viet" typeface="Times New Roman"/>
+        <a:font script="Uigh" typeface="Microsoft Uighur"/>
+        <a:font script="Geor" typeface="Sylfaen"/>
+      </a:majorFont>
+      <a:minorFont>
+        <a:latin typeface="Calibri"/>
+        <a:ea typeface=""/>
+        <a:cs typeface=""/>
+        <a:font script="Jpan" typeface="ＭＳ Ｐゴシック"/>
+        <a:font script="Hang" typeface="맑은 고딕"/>
+        <a:font script="Hans" typeface="宋体"/>
+        <a:font script="Hant" typeface="新細明體"/>
+        <a:font script="Arab" typeface="Arial"/>
+        <a:font script="Hebr" typeface="Arial"/>
+        <a:font script="Thai" typeface="Cordia New"/>
+        <a:font script="Ethi" typeface="Nyala"/>
+        <a:font script="Beng" typeface="Vrinda"/>
+        <a:font script="Gujr" typeface="Shruti"/>
+        <a:font script="Khmr" typeface="DaunPenh"/>
+        <a:font script="Knda" typeface="Tunga"/>
+        <a:font script="Guru" typeface="Raavi"/>
+        <a:font script="Cans" typeface="Euphemia"/>
+        <a:font script="Cher" typeface="Plantagenet Cherokee"/>
+        <a:font script="Yiii" typeface="Microsoft Yi Baiti"/>
+        <a:font script="Tibt" typeface="Microsoft Himalaya"/>
+        <a:font script="Thaa" typeface="MV Boli"/>
+        <a:font script="Deva" typeface="Mangal"/>
+        <a:font script="Telu" typeface="Gautami"/>
+        <a:font script="Taml" typeface="Latha"/>
+        <a:font script="Syrc" typeface="Estrangelo Edessa"/>
+        <a:font script="Orya" typeface="Kalinga"/>
+        <a:font script="Mlym" typeface="Kartika"/>
+        <a:font script="Laoo" typeface="DokChampa"/>
+        <a:font script="Sinh" typeface="Iskoola Pota"/>
+        <a:font script="Mong" typeface="Mongolian Baiti"/>
+        <a:font script="Viet" typeface="Arial"/>
+        <a:font script="Uigh" typeface="Microsoft Uighur"/>
+        <a:font script="Geor" typeface="Sylfaen"/>
+      </a:minorFont>
+    </a:fontScheme>
+    <a:fmtScheme name="Office">
+      <a:fillStyleLst>
+        <a:solidFill>
+          <a:schemeClr val="phClr"/>
+        </a:solidFill>
+        <a:gradFill rotWithShape="1">
+          <a:gsLst>
+            <a:gs pos="0">
+              <a:schemeClr val="phClr">
+                <a:tint val="50000"/>
+                <a:satMod val="300000"/>
+              </a:schemeClr>
+            </a:gs>
+            <a:gs pos="35000">
+              <a:schemeClr val="phClr">
+                <a:tint val="37000"/>
+                <a:satMod val="300000"/>
+              </a:schemeClr>
+            </a:gs>
+            <a:gs pos="100000">
+              <a:schemeClr val="phClr">
+                <a:tint val="15000"/>
+                <a:satMod val="350000"/>
+              </a:schemeClr>
+            </a:gs>
+          </a:gsLst>
+          <a:lin ang="16200000" scaled="1"/>
+        </a:gradFill>
+        <a:gradFill rotWithShape="1">
+          <a:gsLst>
+            <a:gs pos="0">
+              <a:schemeClr val="phClr">
+                <a:tint val="100000"/>
+                <a:shade val="100000"/>
+                <a:satMod val="130000"/>
+              </a:schemeClr>
+            </a:gs>
+            <a:gs pos="100000">
+              <a:schemeClr val="phClr">
+                <a:tint val="50000"/>
+                <a:shade val="100000"/>
+                <a:satMod val="350000"/>
+              </a:schemeClr>
+            </a:gs>
+          </a:gsLst>
+          <a:lin ang="16200000" scaled="0"/>
+        </a:gradFill>
+      </a:fillStyleLst>
+      <a:lnStyleLst>
+        <a:ln w="9525" cap="flat" cmpd="sng" algn="ctr">
+          <a:solidFill>
+            <a:schemeClr val="phClr">
+              <a:shade val="95000"/>
+              <a:satMod val="105000"/>
+            </a:schemeClr>
+          </a:solidFill>
+          <a:prstDash val="solid"/>
+        </a:ln>
+        <a:ln w="25400" cap="flat" cmpd="sng" algn="ctr">
+          <a:solidFill>
+            <a:schemeClr val="phClr"/>
+          </a:solidFill>
+          <a:prstDash val="solid"/>
+        </a:ln>
+        <a:ln w="38100" cap="flat" cmpd="sng" algn="ctr">
+          <a:solidFill>
+            <a:schemeClr val="phClr"/>
+          </a:solidFill>
+          <a:prstDash val="solid"/>
+        </a:ln>
+      </a:lnStyleLst>
+      <a:effectStyleLst>
+        <a:effectStyle>
+          <a:effectLst>
+            <a:outerShdw blurRad="40000" dist="20000" dir="5400000" rotWithShape="0">
+              <a:srgbClr val="000000">
+                <a:alpha val="38000"/>
+              </a:srgbClr>
+            </a:outerShdw>
+          </a:effectLst>
+        </a:effectStyle>
+        <a:effectStyle>
+          <a:effectLst>
+            <a:outerShdw blurRad="40000" dist="23000" dir="5400000" rotWithShape="0">
+              <a:srgbClr val="000000">
+                <a:alpha val="35000"/>
+              </a:srgbClr>
+            </a:outerShdw>
+          </a:effectLst>
+        </a:effectStyle>
+        <a:effectStyle>
+          <a:effectLst>
+            <a:outerShdw blurRad="40000" dist="23000" dir="5400000" rotWithShape="0">
+              <a:srgbClr val="000000">
+                <a:alpha val="35000"/>
+              </a:srgbClr>
+            </a:outerShdw>
+          </a:effectLst>
+          <a:scene3d>
+            <a:camera prst="orthographicFront">
+              <a:rot lat="0" lon="0" rev="0"/>
+            </a:camera>
+            <a:lightRig rig="threePt" dir="t">
+              <a:rot lat="0" lon="0" rev="1200000"/>
+            </a:lightRig>
+          </a:scene3d>
+          <a:sp3d>
+            <a:bevelT w="63500" h="25400"/>
+          </a:sp3d>
+        </a:effectStyle>
+      </a:effectStyleLst>
+      <a:bgFillStyleLst>
+        <a:solidFill>
+          <a:schemeClr val="phClr"/>
+        </a:solidFill>
+        <a:gradFill rotWithShape="1">
+          <a:gsLst>
+            <a:gs pos="0">
+              <a:schemeClr val="phClr">
+                <a:tint val="40000"/>
+                <a:satMod val="350000"/>
+              </a:schemeClr>
+            </a:gs>
+            <a:gs pos="40000">
+              <a:schemeClr val="phClr">
+                <a:tint val="45000"/>
+                <a:shade val="99000"/>
+                <a:satMod val="350000"/>
+              </a:schemeClr>
+            </a:gs>
+            <a:gs pos="100000">
+              <a:schemeClr val="phClr">
+                <a:shade val="20000"/>
+                <a:satMod val="255000"/>
+              </a:schemeClr>
+            </a:gs>
+          </a:gsLst>
+          <a:path path="circle">
+            <a:fillToRect l="50000" t="-80000" r="50000" b="180000"/>
+          </a:path>
+        </a:gradFill>
+        <a:gradFill rotWithShape="1">
+          <a:gsLst>
+            <a:gs pos="0">
+              <a:schemeClr val="phClr">
+                <a:tint val="80000"/>
+                <a:satMod val="300000"/>
+              </a:schemeClr>
+            </a:gs>
+            <a:gs pos="100000">
+              <a:schemeClr val="phClr">
+                <a:shade val="30000"/>
+                <a:satMod val="200000"/>
+              </a:schemeClr>
+            </a:gs>
+          </a:gsLst>
+          <a:path path="circle">
+            <a:fillToRect l="50000" t="50000" r="50000" b="50000"/>
+          </a:path>
+        </a:gradFill>
+      </a:bgFillStyleLst>
+    </a:fmtScheme>
+  </a:themeElements>
+  <a:objectDefaults>
+    <a:spDef>
+      <a:spPr/>
+      <a:bodyPr/>
+      <a:lstStyle/>
+      <a:style>
+        <a:lnRef idx="1">
+          <a:schemeClr val="accent1"/>
+        </a:lnRef>
+        <a:fillRef idx="3">
+          <a:schemeClr val="accent1"/>
+        </a:fillRef>
+        <a:effectRef idx="2">
+          <a:schemeClr val="accent1"/>
+        </a:effectRef>
+        <a:fontRef idx="minor">
+          <a:schemeClr val="lt1"/>
+        </a:fontRef>
+      </a:style>
+    </a:spDef>
+    <a:lnDef>
+      <a:spPr/>
+      <a:bodyPr/>
+      <a:lstStyle/>
+      <a:style>
+        <a:lnRef idx="2">
+          <a:schemeClr val="accent1"/>
+        </a:lnRef>
+        <a:fillRef idx="0">
+          <a:schemeClr val="accent1"/>
+        </a:fillRef>
+        <a:effectRef idx="1">
+          <a:schemeClr val="accent1"/>
+        </a:effectRef>
+        <a:fontRef idx="minor">
+          <a:schemeClr val="tx1"/>
+        </a:fontRef>
+      </a:style>
+    </a:lnDef>
+  </a:objectDefaults>
+  <a:extraClrSchemeLst/>
+</a:theme>
 </file>
</xml_diff>

<commit_message>
Corregir informe EP3 segun retroalimentacion y agregar evidencias crudas
- Anexo F con peticiones curl y respuestas HTTP reales (14 casos CP y 13 bloques SEG)
- Matriz de trazabilidad con IDs reales del ERS y cobertura declarada (28,6 % plena, 42,9 % parcial)
- RF-5.2 corregido: PDF, DOC, PPT, JPG y PNG
- CP-013 de rendimiento (5 mediciones, promedio 4,011 s) registrado como FALLO
- CP-014 de usabilidad y accesibilidad (Lighthouse 0,96)
- Resumen: 14 casos, 11 pass / 3 fail (78,6 %); 12 incidentes
- Cronograma de ejecucion (3.5) y fecha/ejecutor en el detalle (5.2)
- Script de pruebas renumerado CP-001..CP-014
- PPT y guion de defensa sincronizados
</commit_message>
<xml_diff>
--- a/EP3_Presentacion_Atlas.pptx
+++ b/EP3_Presentacion_Atlas.pptx
@@ -4749,7 +4749,7 @@
                 </a:solidFill>
                 <a:latin typeface="Arial"/>
               </a:rPr>
-              <a:t>Docente: Christian Rodrigo Alvarez Lobos    ·    Fecha: 17 de octubre de 2026</a:t>
+              <a:t>Docente: Christian Rodrigo Alvarez Lobos    ·    Fecha: 29 de octubre de 2026 · versión revisada</a:t>
             </a:r>
           </a:p>
           <a:p>
@@ -5199,14 +5199,15 @@
                     <a:bodyPr wrap="square"/>
                     <a:lstStyle/>
                     <a:p>
+                      <a:pPr/>
                       <a:r>
-                        <a:rPr sz="1300" b="0" i="0">
+                        <a:rPr sz="1300" b="0">
                           <a:solidFill>
                             <a:srgbClr val="212529"/>
                           </a:solidFill>
                           <a:latin typeface="Arial"/>
                         </a:rPr>
-                        <a:t>5</a:t>
+                        <a:t>6</a:t>
                       </a:r>
                     </a:p>
                   </a:txBody>
@@ -5228,7 +5229,7 @@
                           </a:solidFill>
                           <a:latin typeface="Arial"/>
                         </a:rPr>
-                        <a:t>JWT_SECRET "inseguro" · CORS * · sin rate-limit · errores 500 · localStorage</a:t>
+                        <a:t>JWT_SECRET "inseguro" · CORS * · sin rate-limit · errores 500 · localStorage · BUG-010 latencia 4 s</a:t>
                       </a:r>
                     </a:p>
                   </a:txBody>
@@ -5289,6 +5290,7 @@
                     <a:bodyPr wrap="square"/>
                     <a:lstStyle/>
                     <a:p>
+                      <a:pPr/>
                       <a:r>
                         <a:rPr sz="1300" b="0" i="0">
                           <a:solidFill>
@@ -5318,7 +5320,7 @@
                           </a:solidFill>
                           <a:latin typeface="Arial"/>
                         </a:rPr>
-                        <a:t>BUG-010 latencia artificial de 4 s</a:t>
+                        <a:t>BUG-012 contraste e idioma</a:t>
                       </a:r>
                     </a:p>
                   </a:txBody>
@@ -6013,7 +6015,7 @@
                 </a:solidFill>
                 <a:latin typeface="Arial"/>
               </a:rPr>
-              <a:t> base funcional correcta (83% Pass), pero deuda técnica alta en el frontend (181 code smells) y bug de compatibilidad React 19.</a:t>
+              <a:t> base funcional correcta (78,6% Pass), pero deuda técnica alta en el frontend (181 code smells) y bug de compatibilidad React 19.</a:t>
             </a:r>
           </a:p>
           <a:p>
@@ -6500,7 +6502,7 @@
                 </a:solidFill>
                 <a:latin typeface="Arial"/>
               </a:rPr>
-              <a:t>Validación de tipo MIME/extensión en uploads — solo PDF (BUG-003).</a:t>
+              <a:t>Validación de MIME/extensión en uploads — PDF, DOC, PPT, JPG y PNG (BUG-003).</a:t>
             </a:r>
           </a:p>
           <a:p>
@@ -7919,7 +7921,7 @@
                 </a:solidFill>
                 <a:latin typeface="Arial"/>
               </a:rPr>
-              <a:t> 12 casos funcionales y de seguridad + pruebas complementarias.</a:t>
+              <a:t> 14 casos: 12 funcionales/seguridad + 2 no funcionales (rendimiento y usabilidad), más pruebas complementarias.</a:t>
             </a:r>
           </a:p>
           <a:p>
@@ -9524,7 +9526,7 @@
                           </a:solidFill>
                           <a:latin typeface="Arial"/>
                         </a:rPr>
-                        <a:t>12 / 12 (100%)</a:t>
+                        <a:t>14 / 14 (100%)</a:t>
                       </a:r>
                     </a:p>
                   </a:txBody>
@@ -9570,7 +9572,7 @@
                           </a:solidFill>
                           <a:latin typeface="Arial"/>
                         </a:rPr>
-                        <a:t>10 (83%)</a:t>
+                        <a:t>11 (78,6%)</a:t>
                       </a:r>
                     </a:p>
                   </a:txBody>
@@ -9616,7 +9618,7 @@
                           </a:solidFill>
                           <a:latin typeface="Arial"/>
                         </a:rPr>
-                        <a:t>2 → CP-010 (upload .exe) y CP-011 (acceso sin token)</a:t>
+                        <a:t>3 → CP-010 (upload .exe), CP-011 (sin token) y CP-013 (rendimiento)</a:t>
                       </a:r>
                     </a:p>
                   </a:txBody>
@@ -9708,7 +9710,7 @@
                           </a:solidFill>
                           <a:latin typeface="Arial"/>
                         </a:rPr>
-                        <a:t>11  →  4 CRITICO · 5 GRAVE · 1 MODERADO · 1 LEVE</a:t>
+                        <a:t>12  →  4 CRITICO · 6 GRAVE · 1 MODERADO · 1 LEVE</a:t>
                       </a:r>
                     </a:p>
                   </a:txBody>
@@ -9800,7 +9802,7 @@
                           </a:solidFill>
                           <a:latin typeface="Arial"/>
                         </a:rPr>
-                        <a:t>~4,0 s (latencia artificial)</a:t>
+                        <a:t>4,011 s (promedio de 5 mediciones; latencia artificial)</a:t>
                       </a:r>
                     </a:p>
                   </a:txBody>
@@ -9844,7 +9846,7 @@
                 </a:solidFill>
                 <a:latin typeface="Arial"/>
               </a:rPr>
-              <a:t>Resultado global: 83% de éxito, con 2 fallos de seguridad CRITICO que bloquean la certificación.</a:t>
+              <a:t>Resultado global: 78,6% de éxito, con 2 fallos de seguridad CRITICO y 1 de rendimiento que bloquean la certificación.</a:t>
             </a:r>
           </a:p>
         </p:txBody>
@@ -10691,7 +10693,7 @@
                           </a:solidFill>
                           <a:latin typeface="Arial"/>
                         </a:rPr>
-                        <a:t>FN-02</a:t>
+                        <a:t>CP-013</a:t>
                       </a:r>
                     </a:p>
                   </a:txBody>
@@ -10713,7 +10715,7 @@
                           </a:solidFill>
                           <a:latin typeface="Arial"/>
                         </a:rPr>
-                        <a:t>Tiempo de respuesta GET /clientes</a:t>
+                        <a:t>Tiempo de respuesta GET /clientes (5 mediciones)</a:t>
                       </a:r>
                     </a:p>
                   </a:txBody>
@@ -10735,7 +10737,97 @@
                           </a:solidFill>
                           <a:latin typeface="Arial"/>
                         </a:rPr>
-                        <a:t>~4,06 s (umbral 300 ms)</a:t>
+                        <a:t>4,011 s prom. (umbral 300 ms)</a:t>
+                      </a:r>
+                    </a:p>
+                  </a:txBody>
+                  <a:tcPr marL="54864" marR="54864" marT="18288" marB="18288" anchor="ctr">
+                    <a:solidFill>
+                      <a:srgbClr val="FFFFFF"/>
+                    </a:solidFill>
+                  </a:tcPr>
+                </a:tc>
+                <a:tc>
+                  <a:txBody>
+                    <a:bodyPr wrap="square"/>
+                    <a:lstStyle/>
+                    <a:p>
+                      <a:r>
+                        <a:rPr sz="1400" b="0" i="0">
+                          <a:solidFill>
+                            <a:srgbClr val="212529"/>
+                          </a:solidFill>
+                          <a:latin typeface="Arial"/>
+                        </a:rPr>
+                        <a:t>GRAVE</a:t>
+                      </a:r>
+                    </a:p>
+                  </a:txBody>
+                  <a:tcPr marL="54864" marR="54864" marT="18288" marB="18288" anchor="ctr">
+                    <a:solidFill>
+                      <a:srgbClr val="FFFFFF"/>
+                    </a:solidFill>
+                  </a:tcPr>
+                </a:tc>
+              </a:tr>
+              <a:tr h="537210">
+                <a:tc>
+                  <a:txBody>
+                    <a:bodyPr wrap="square"/>
+                    <a:lstStyle/>
+                    <a:p>
+                      <a:r>
+                        <a:rPr sz="1400" b="0" i="0">
+                          <a:solidFill>
+                            <a:srgbClr val="212529"/>
+                          </a:solidFill>
+                          <a:latin typeface="Arial"/>
+                        </a:rPr>
+                        <a:t>CP-014</a:t>
+                      </a:r>
+                    </a:p>
+                  </a:txBody>
+                  <a:tcPr marL="54864" marR="54864" marT="18288" marB="18288" anchor="ctr">
+                    <a:solidFill>
+                      <a:srgbClr val="FFFFFF"/>
+                    </a:solidFill>
+                  </a:tcPr>
+                </a:tc>
+                <a:tc>
+                  <a:txBody>
+                    <a:bodyPr wrap="square"/>
+                    <a:lstStyle/>
+                    <a:p>
+                      <a:r>
+                        <a:rPr sz="1400" b="0" i="0">
+                          <a:solidFill>
+                            <a:srgbClr val="212529"/>
+                          </a:solidFill>
+                          <a:latin typeface="Arial"/>
+                        </a:rPr>
+                        <a:t>Usabilidad y accesibilidad del login (Lighthouse)</a:t>
+                      </a:r>
+                    </a:p>
+                  </a:txBody>
+                  <a:tcPr marL="54864" marR="54864" marT="18288" marB="18288" anchor="ctr">
+                    <a:solidFill>
+                      <a:srgbClr val="FFFFFF"/>
+                    </a:solidFill>
+                  </a:tcPr>
+                </a:tc>
+                <a:tc>
+                  <a:txBody>
+                    <a:bodyPr wrap="square"/>
+                    <a:lstStyle/>
+                    <a:p>
+                      <a:r>
+                        <a:rPr sz="1400" b="0" i="0">
+                          <a:solidFill>
+                            <a:srgbClr val="212529"/>
+                          </a:solidFill>
+                          <a:latin typeface="Arial"/>
+                        </a:rPr>
+                        <a:t>Aprobado con observaciones (0,96)</a:t>
                       </a:r>
                     </a:p>
                   </a:txBody>

</xml_diff>